<commit_message>
Fix slide 3 callout alignment — match card edges
Co-Authored-By: Claude Opus 4.6 (1M context) <noreply@anthropic.com>
</commit_message>
<xml_diff>
--- a/Rainbow_Conference_2026_Media_Mix.pptx
+++ b/Rainbow_Conference_2026_Media_Mix.pptx
@@ -6321,8 +6321,8 @@
         </p:nvSpPr>
         <p:spPr>
           <a:xfrm>
-            <a:off x="731520" y="4663440"/>
-            <a:ext cx="10515600" cy="640080"/>
+            <a:off x="1097280" y="4663440"/>
+            <a:ext cx="10241280" cy="640080"/>
           </a:xfrm>
           <a:prstGeom prst="rect">
             <a:avLst/>
@@ -6364,7 +6364,7 @@
         </p:nvSpPr>
         <p:spPr>
           <a:xfrm>
-            <a:off x="731520" y="4663440"/>
+            <a:off x="1097280" y="4663440"/>
             <a:ext cx="63500" cy="640080"/>
           </a:xfrm>
           <a:prstGeom prst="rect">
@@ -6407,8 +6407,8 @@
         </p:nvSpPr>
         <p:spPr>
           <a:xfrm>
-            <a:off x="960120" y="4736592"/>
-            <a:ext cx="10195560" cy="493776"/>
+            <a:off x="1325880" y="4736592"/>
+            <a:ext cx="10012680" cy="493776"/>
           </a:xfrm>
           <a:prstGeom prst="rect">
             <a:avLst/>

</xml_diff>